<commit_message>
PPT: architecture slide with all five nodes, the hand-off and re-planning
The slide still showed four nodes and the first detector. It now shows
package_handoff, the /handoff and /ebot_obstacles links, the depth-and-vote
perception, and arrows back into Gazebo pointing the right way. The closing
slide's notes no longer call the hand-off a next step.

Co-Authored-By: Claude Opus 5.5 <noreply@anthropic.com>
Claude-Session: https://claude.ai/code/session_01YNWqoHgsE8xF4Djryys7h9
</commit_message>
<xml_diff>
--- a/docs/Strata_Cobot_Presentation.pptx
+++ b/docs/Strata_Cobot_Presentation.pptx
@@ -121,7 +121,7 @@
   <p:extLst>
     <p:ext uri="{521415D9-36F7-43E2-AB2F-B90AF26B5E84}">
       <p14:sectionLst xmlns:p14="http://schemas.microsoft.com/office/powerpoint/2010/main">
-        <p14:section name="Introduction" id="{5de1d366-0854-39de-df3d-80345f57665a}">
+        <p14:section name="Introduction" id="{c9a7873b-203f-02d0-018f-f8425bd7d58c}">
           <p14:sldIdLst>
             <p14:sldId id="256"/>
             <p14:sldId id="257"/>
@@ -129,7 +129,7 @@
             <p14:sldId id="259"/>
           </p14:sldIdLst>
         </p14:section>
-        <p14:section name="The manipulator" id="{0b24578b-af5f-b63a-0c6f-c4f7f6269597}">
+        <p14:section name="The manipulator" id="{6939283a-27e1-852f-4837-51aac4a9cefa}">
           <p14:sldIdLst>
             <p14:sldId id="260"/>
             <p14:sldId id="261"/>
@@ -138,13 +138,13 @@
             <p14:sldId id="264"/>
           </p14:sldIdLst>
         </p14:section>
-        <p14:section name="The mobile robot" id="{4a278b7f-aede-0643-606a-1fe985082213}">
+        <p14:section name="The mobile robot" id="{fce54d1c-6e7c-1ee0-e682-a0f7cc390057}">
           <p14:sldIdLst>
             <p14:sldId id="265"/>
             <p14:sldId id="266"/>
           </p14:sldIdLst>
         </p14:section>
-        <p14:section name="Results" id="{c8b2878b-80dd-81fb-30b4-7f7645fd9d21}">
+        <p14:section name="Results" id="{a712679d-0c89-e6ce-6e8f-49ae955d5234}">
           <p14:sldIdLst>
             <p14:sldId id="267"/>
             <p14:sldId id="268"/>
@@ -1426,7 +1426,7 @@
           <a:p>
             <a:r>
               <a:rPr lang="en-US" dirty="0"/>
-              <a:t>To sum up: both halves of the mission work end to end in simulation, using only algorithms we wrote. The natural next step is the handoff, where the eBot delivers ore to the arm. Happy to take questions, and we can run a live demo.</a:t>
+              <a:t>To sum up: both halves of the mission work end to end in simulation, using only algorithms we wrote. The two robots also work together: the eBot delivers the ore package to the arm, which lifts it onto the conveyor, and the eBot re-plans around rocks it did not expect. The natural next steps are a classifier trained on real ore samples and physical robots. Happy to take questions, and we can run a live demo.</a:t>
             </a:r>
             <a:endParaRPr lang="en-US" dirty="0"/>
           </a:p>
@@ -1690,7 +1690,7 @@
           <a:p>
             <a:r>
               <a:rPr lang="en-US" dirty="0"/>
-              <a:t>Two Python nodes per robot. Note the arrows into the simulation: the arm accepts only velocity commands and the eBot only velocity twists, so every node closes its own control loop at 20 to 50 Hz. The two highlighted nodes hold most of the algorithmic work.</a:t>
+              <a:t>Two Python nodes per robot, plus package_handoff, which extends the arm node for the full mission: the planner says the eBot is in place on /handoff/ready, the arm lifts the package onto the conveyor and answers on /handoff/done. The follower reports anything its lidar sees that the map lacks on /ebot_obstacles, and the planner re-plans. The arm accepts only velocity commands and the eBot only velocity twists, so every node closes its own control loop at 20 to 50 Hz. The two highlighted nodes hold most of the algorithmic work.</a:t>
             </a:r>
             <a:endParaRPr lang="en-US" dirty="0"/>
           </a:p>
@@ -9364,7 +9364,7 @@
                   <a:schemeClr val="tx1"/>
                 </a:solidFill>
               </a:rPr>
-              <a:t>Four nodes, two sense-plan-act pipelines</a:t>
+              <a:t>Five nodes, two sense-plan-act pipelines and a hand-off</a:t>
             </a:r>
             <a:endParaRPr lang="en-US" sz="3200" dirty="0"/>
           </a:p>
@@ -9379,7 +9379,7 @@
         <p:spPr>
           <a:xfrm>
             <a:off x="548640" y="1371600"/>
-            <a:ext cx="2377440" cy="4754880"/>
+            <a:ext cx="2377440" cy="4480560"/>
           </a:xfrm>
           <a:prstGeom prst="roundRect">
             <a:avLst>
@@ -9405,8 +9405,8 @@
         </p:nvSpPr>
         <p:spPr>
           <a:xfrm>
-            <a:off x="731520" y="1508760"/>
-            <a:ext cx="2011680" cy="365760"/>
+            <a:off x="731520" y="1481328"/>
+            <a:ext cx="2011680" cy="320040"/>
           </a:xfrm>
           <a:prstGeom prst="rect">
             <a:avLst/>
@@ -9441,8 +9441,8 @@
         </p:nvSpPr>
         <p:spPr>
           <a:xfrm>
-            <a:off x="731520" y="1920240"/>
-            <a:ext cx="2011680" cy="4114800"/>
+            <a:off x="731520" y="1828800"/>
+            <a:ext cx="2011680" cy="3977640"/>
           </a:xfrm>
           <a:prstGeom prst="rect">
             <a:avLst/>
@@ -9458,76 +9458,76 @@
               <a:buNone/>
             </a:pPr>
             <a:r>
-              <a:rPr lang="en-US" sz="1300" dirty="0">
+              <a:rPr lang="en-US" sz="1250" dirty="0">
                 <a:solidFill>
                   <a:schemeClr val="tx2"/>
                 </a:solidFill>
               </a:rPr>
               <a:t>UR7e arm + magnet</a:t>
             </a:r>
-            <a:endParaRPr lang="en-US" sz="1300" dirty="0"/>
-          </a:p>
-          <a:p>
-            <a:pPr indent="0" marL="0">
-              <a:buNone/>
-            </a:pPr>
-            <a:r>
-              <a:rPr lang="en-US" sz="1300" dirty="0">
+            <a:endParaRPr lang="en-US" sz="1250" dirty="0"/>
+          </a:p>
+          <a:p>
+            <a:pPr indent="0" marL="0">
+              <a:buNone/>
+            </a:pPr>
+            <a:r>
+              <a:rPr lang="en-US" sz="1250" dirty="0">
                 <a:solidFill>
                   <a:schemeClr val="tx2"/>
                 </a:solidFill>
               </a:rPr>
               <a:t>RealSense D435i</a:t>
             </a:r>
-            <a:endParaRPr lang="en-US" sz="1300" dirty="0"/>
-          </a:p>
-          <a:p>
-            <a:pPr indent="0" marL="0">
-              <a:buNone/>
-            </a:pPr>
-            <a:r>
-              <a:rPr lang="en-US" sz="1300" dirty="0">
+            <a:endParaRPr lang="en-US" sz="1250" dirty="0"/>
+          </a:p>
+          <a:p>
+            <a:pPr indent="0" marL="0">
+              <a:buNone/>
+            </a:pPr>
+            <a:r>
+              <a:rPr lang="en-US" sz="1250" dirty="0">
                 <a:solidFill>
                   <a:schemeClr val="tx2"/>
                 </a:solidFill>
               </a:rPr>
               <a:t>eBot + lidar</a:t>
             </a:r>
-            <a:endParaRPr lang="en-US" sz="1300" dirty="0"/>
-          </a:p>
-          <a:p>
-            <a:pPr indent="0" marL="0">
-              <a:buNone/>
-            </a:pPr>
-            <a:r>
-              <a:rPr lang="en-US" sz="1300" dirty="0">
+            <a:endParaRPr lang="en-US" sz="1250" dirty="0"/>
+          </a:p>
+          <a:p>
+            <a:pPr indent="0" marL="0">
+              <a:buNone/>
+            </a:pPr>
+            <a:r>
+              <a:rPr lang="en-US" sz="1250" dirty="0">
                 <a:solidFill>
                   <a:schemeClr val="tx2"/>
                 </a:solidFill>
               </a:rPr>
               <a:t>rocks and /map</a:t>
             </a:r>
-            <a:endParaRPr lang="en-US" sz="1300" dirty="0"/>
-          </a:p>
-          <a:p>
-            <a:pPr indent="0" marL="0">
-              <a:buNone/>
-            </a:pPr>
-            <a:endParaRPr lang="en-US" sz="1300" dirty="0"/>
-          </a:p>
-          <a:p>
-            <a:pPr indent="0" marL="0">
-              <a:buNone/>
-            </a:pPr>
-            <a:r>
-              <a:rPr lang="en-US" sz="1300" dirty="0">
+            <a:endParaRPr lang="en-US" sz="1250" dirty="0"/>
+          </a:p>
+          <a:p>
+            <a:pPr indent="0" marL="0">
+              <a:buNone/>
+            </a:pPr>
+            <a:endParaRPr lang="en-US" sz="1250" dirty="0"/>
+          </a:p>
+          <a:p>
+            <a:pPr indent="0" marL="0">
+              <a:buNone/>
+            </a:pPr>
+            <a:r>
+              <a:rPr lang="en-US" sz="1250" dirty="0">
                 <a:solidFill>
                   <a:schemeClr val="tx2"/>
                 </a:solidFill>
               </a:rPr>
               <a:t>ROS 2 Jazzy bridge</a:t>
             </a:r>
-            <a:endParaRPr lang="en-US" sz="1300" dirty="0"/>
+            <a:endParaRPr lang="en-US" sz="1250" dirty="0"/>
           </a:p>
         </p:txBody>
       </p:sp>
@@ -9539,7 +9539,7 @@
         </p:nvSpPr>
         <p:spPr>
           <a:xfrm>
-            <a:off x="4023360" y="1325880"/>
+            <a:off x="4023360" y="1280160"/>
             <a:ext cx="2743200" cy="274320"/>
           </a:xfrm>
           <a:prstGeom prst="rect">
@@ -9575,12 +9575,12 @@
         </p:nvSpPr>
         <p:spPr>
           <a:xfrm>
-            <a:off x="4023360" y="1645920"/>
-            <a:ext cx="3108960" cy="1554480"/>
+            <a:off x="4023360" y="1600200"/>
+            <a:ext cx="3108960" cy="1325880"/>
           </a:xfrm>
           <a:prstGeom prst="roundRect">
             <a:avLst>
-              <a:gd name="adj" fmla="val 4706"/>
+              <a:gd name="adj" fmla="val 5517"/>
             </a:avLst>
           </a:prstGeom>
           <a:solidFill>
@@ -9602,8 +9602,8 @@
         </p:nvSpPr>
         <p:spPr>
           <a:xfrm>
-            <a:off x="4206240" y="1783080"/>
-            <a:ext cx="2743200" cy="365760"/>
+            <a:off x="4206240" y="1709928"/>
+            <a:ext cx="2743200" cy="320040"/>
           </a:xfrm>
           <a:prstGeom prst="rect">
             <a:avLst/>
@@ -9638,8 +9638,8 @@
         </p:nvSpPr>
         <p:spPr>
           <a:xfrm>
-            <a:off x="4206240" y="2194560"/>
-            <a:ext cx="2743200" cy="914400"/>
+            <a:off x="4206240" y="2057400"/>
+            <a:ext cx="2743200" cy="822960"/>
           </a:xfrm>
           <a:prstGeom prst="rect">
             <a:avLst/>
@@ -9655,42 +9655,42 @@
               <a:buNone/>
             </a:pPr>
             <a:r>
-              <a:rPr lang="en-US" sz="1300" dirty="0">
+              <a:rPr lang="en-US" sz="1250" dirty="0">
                 <a:solidFill>
                   <a:schemeClr val="tx2"/>
                 </a:solidFill>
               </a:rPr>
-              <a:t>HSV face detection</a:t>
-            </a:r>
-            <a:endParaRPr lang="en-US" sz="1300" dirty="0"/>
-          </a:p>
-          <a:p>
-            <a:pPr indent="0" marL="0">
-              <a:buNone/>
-            </a:pPr>
-            <a:r>
-              <a:rPr lang="en-US" sz="1300" dirty="0">
+              <a:t>find each ore by depth and shape</a:t>
+            </a:r>
+            <a:endParaRPr lang="en-US" sz="1250" dirty="0"/>
+          </a:p>
+          <a:p>
+            <a:pPr indent="0" marL="0">
+              <a:buNone/>
+            </a:pPr>
+            <a:r>
+              <a:rPr lang="en-US" sz="1250" dirty="0">
                 <a:solidFill>
                   <a:schemeClr val="tx2"/>
                 </a:solidFill>
               </a:rPr>
-              <a:t>depth back-projection</a:t>
-            </a:r>
-            <a:endParaRPr lang="en-US" sz="1300" dirty="0"/>
-          </a:p>
-          <a:p>
-            <a:pPr indent="0" marL="0">
-              <a:buNone/>
-            </a:pPr>
-            <a:r>
-              <a:rPr lang="en-US" sz="1300" dirty="0">
+              <a:t>name it by a colour vote</a:t>
+            </a:r>
+            <a:endParaRPr lang="en-US" sz="1250" dirty="0"/>
+          </a:p>
+          <a:p>
+            <a:pPr indent="0" marL="0">
+              <a:buNone/>
+            </a:pPr>
+            <a:r>
+              <a:rPr lang="en-US" sz="1250" dirty="0">
                 <a:solidFill>
                   <a:schemeClr val="tx2"/>
                 </a:solidFill>
               </a:rPr>
-              <a:t>median per ore</a:t>
-            </a:r>
-            <a:endParaRPr lang="en-US" sz="1300" dirty="0"/>
+              <a:t>tf frame per ore</a:t>
+            </a:r>
+            <a:endParaRPr lang="en-US" sz="1250" dirty="0"/>
           </a:p>
         </p:txBody>
       </p:sp>
@@ -9702,12 +9702,12 @@
         </p:nvSpPr>
         <p:spPr>
           <a:xfrm>
-            <a:off x="8321040" y="1645920"/>
-            <a:ext cx="3291840" cy="1554480"/>
+            <a:off x="8321040" y="1600200"/>
+            <a:ext cx="3291840" cy="1325880"/>
           </a:xfrm>
           <a:prstGeom prst="roundRect">
             <a:avLst>
-              <a:gd name="adj" fmla="val 4706"/>
+              <a:gd name="adj" fmla="val 5517"/>
             </a:avLst>
           </a:prstGeom>
           <a:solidFill>
@@ -9729,8 +9729,8 @@
         </p:nvSpPr>
         <p:spPr>
           <a:xfrm>
-            <a:off x="8503920" y="1783080"/>
-            <a:ext cx="2926080" cy="365760"/>
+            <a:off x="8503920" y="1709928"/>
+            <a:ext cx="2926080" cy="320040"/>
           </a:xfrm>
           <a:prstGeom prst="rect">
             <a:avLst/>
@@ -9765,8 +9765,8 @@
         </p:nvSpPr>
         <p:spPr>
           <a:xfrm>
-            <a:off x="8503920" y="2194560"/>
-            <a:ext cx="2926080" cy="914400"/>
+            <a:off x="8503920" y="2057400"/>
+            <a:ext cx="2926080" cy="822960"/>
           </a:xfrm>
           <a:prstGeom prst="rect">
             <a:avLst/>
@@ -9782,95 +9782,194 @@
               <a:buNone/>
             </a:pPr>
             <a:r>
-              <a:rPr lang="en-US" sz="1300" dirty="0">
+              <a:rPr lang="en-US" sz="1250" dirty="0">
                 <a:solidFill>
                   <a:schemeClr val="tx2"/>
                 </a:solidFill>
               </a:rPr>
               <a:t>damped least-squares IK</a:t>
             </a:r>
-            <a:endParaRPr lang="en-US" sz="1300" dirty="0"/>
-          </a:p>
-          <a:p>
-            <a:pPr indent="0" marL="0">
-              <a:buNone/>
-            </a:pPr>
-            <a:r>
-              <a:rPr lang="en-US" sz="1300" dirty="0">
+            <a:endParaRPr lang="en-US" sz="1250" dirty="0"/>
+          </a:p>
+          <a:p>
+            <a:pPr indent="0" marL="0">
+              <a:buNone/>
+            </a:pPr>
+            <a:r>
+              <a:rPr lang="en-US" sz="1250" dirty="0">
                 <a:solidFill>
                   <a:schemeClr val="tx2"/>
                 </a:solidFill>
               </a:rPr>
               <a:t>collision-checked routes</a:t>
             </a:r>
-            <a:endParaRPr lang="en-US" sz="1300" dirty="0"/>
-          </a:p>
-          <a:p>
-            <a:pPr indent="0" marL="0">
-              <a:buNone/>
-            </a:pPr>
-            <a:r>
-              <a:rPr lang="en-US" sz="1300" dirty="0">
+            <a:endParaRPr lang="en-US" sz="1250" dirty="0"/>
+          </a:p>
+          <a:p>
+            <a:pPr indent="0" marL="0">
+              <a:buNone/>
+            </a:pPr>
+            <a:r>
+              <a:rPr lang="en-US" sz="1250" dirty="0">
                 <a:solidFill>
                   <a:schemeClr val="tx2"/>
                 </a:solidFill>
               </a:rPr>
               <a:t>force-checked picks</a:t>
             </a:r>
-            <a:endParaRPr lang="en-US" sz="1300" dirty="0"/>
-          </a:p>
-        </p:txBody>
-      </p:sp>
-      <p:sp>
-        <p:nvSpPr>
-          <p:cNvPr id="13" name="Text 11"/>
-          <p:cNvSpPr txBox="1"/>
-          <p:nvPr/>
-        </p:nvSpPr>
-        <p:spPr>
-          <a:xfrm>
-            <a:off x="4023360" y="3794760"/>
-            <a:ext cx="2743200" cy="274320"/>
-          </a:xfrm>
-          <a:prstGeom prst="rect">
-            <a:avLst/>
-          </a:prstGeom>
-          <a:noFill/>
-          <a:ln/>
-        </p:spPr>
-        <p:txBody>
-          <a:bodyPr wrap="square" lIns="0" tIns="0" rIns="0" bIns="0" rtlCol="0" anchor="t"/>
-          <a:lstStyle/>
-          <a:p>
-            <a:pPr indent="0" marL="0">
-              <a:buNone/>
-            </a:pPr>
-            <a:r>
-              <a:rPr lang="en-US" sz="1300" dirty="0">
-                <a:solidFill>
-                  <a:schemeClr val="accent5"/>
-                </a:solidFill>
-              </a:rPr>
-              <a:t>Mobile robot</a:t>
-            </a:r>
-            <a:endParaRPr lang="en-US" sz="1300" dirty="0"/>
-          </a:p>
-        </p:txBody>
-      </p:sp>
-      <p:sp>
-        <p:nvSpPr>
-          <p:cNvPr id="14" name="node-planning"/>
+            <a:endParaRPr lang="en-US" sz="1250" dirty="0"/>
+          </a:p>
+        </p:txBody>
+      </p:sp>
+      <p:sp>
+        <p:nvSpPr>
+          <p:cNvPr id="13" name="node-handoff"/>
           <p:cNvSpPr/>
           <p:nvPr/>
         </p:nvSpPr>
         <p:spPr>
           <a:xfrm>
-            <a:off x="4023360" y="4114800"/>
-            <a:ext cx="3108960" cy="1554480"/>
+            <a:off x="8321040" y="3429000"/>
+            <a:ext cx="3291840" cy="868680"/>
           </a:xfrm>
           <a:prstGeom prst="roundRect">
             <a:avLst>
-              <a:gd name="adj" fmla="val 4706"/>
+              <a:gd name="adj" fmla="val 8421"/>
+            </a:avLst>
+          </a:prstGeom>
+          <a:solidFill>
+            <a:srgbClr val="FFFFFF"/>
+          </a:solidFill>
+          <a:ln w="12700">
+            <a:solidFill>
+              <a:srgbClr val="6B7280"/>
+            </a:solidFill>
+            <a:prstDash val="solid"/>
+          </a:ln>
+        </p:spPr>
+      </p:sp>
+      <p:sp>
+        <p:nvSpPr>
+          <p:cNvPr id="14" name="Text 12"/>
+          <p:cNvSpPr txBox="1"/>
+          <p:nvPr/>
+        </p:nvSpPr>
+        <p:spPr>
+          <a:xfrm>
+            <a:off x="8503920" y="3538728"/>
+            <a:ext cx="2926080" cy="320040"/>
+          </a:xfrm>
+          <a:prstGeom prst="rect">
+            <a:avLst/>
+          </a:prstGeom>
+          <a:noFill/>
+          <a:ln/>
+        </p:spPr>
+        <p:txBody>
+          <a:bodyPr wrap="square" lIns="0" tIns="0" rIns="0" bIns="0" rtlCol="0" anchor="t"/>
+          <a:lstStyle/>
+          <a:p>
+            <a:pPr indent="0" marL="0">
+              <a:buNone/>
+            </a:pPr>
+            <a:r>
+              <a:rPr lang="en-US" sz="1600" b="1" dirty="0">
+                <a:solidFill>
+                  <a:schemeClr val="tx1"/>
+                </a:solidFill>
+              </a:rPr>
+              <a:t>package_handoff</a:t>
+            </a:r>
+            <a:endParaRPr lang="en-US" sz="1600" dirty="0"/>
+          </a:p>
+        </p:txBody>
+      </p:sp>
+      <p:sp>
+        <p:nvSpPr>
+          <p:cNvPr id="15" name="Text 13"/>
+          <p:cNvSpPr txBox="1"/>
+          <p:nvPr/>
+        </p:nvSpPr>
+        <p:spPr>
+          <a:xfrm>
+            <a:off x="8503920" y="3886200"/>
+            <a:ext cx="2926080" cy="365760"/>
+          </a:xfrm>
+          <a:prstGeom prst="rect">
+            <a:avLst/>
+          </a:prstGeom>
+          <a:noFill/>
+          <a:ln/>
+        </p:spPr>
+        <p:txBody>
+          <a:bodyPr wrap="square" lIns="0" tIns="0" rIns="0" bIns="0" rtlCol="0" anchor="t"/>
+          <a:lstStyle/>
+          <a:p>
+            <a:pPr indent="0" marL="0">
+              <a:buNone/>
+            </a:pPr>
+            <a:r>
+              <a:rPr lang="en-US" sz="1250" dirty="0">
+                <a:solidFill>
+                  <a:schemeClr val="tx2"/>
+                </a:solidFill>
+              </a:rPr>
+              <a:t>lifts the package off the eBot onto the conveyor</a:t>
+            </a:r>
+            <a:endParaRPr lang="en-US" sz="1250" dirty="0"/>
+          </a:p>
+        </p:txBody>
+      </p:sp>
+      <p:sp>
+        <p:nvSpPr>
+          <p:cNvPr id="16" name="Text 14"/>
+          <p:cNvSpPr txBox="1"/>
+          <p:nvPr/>
+        </p:nvSpPr>
+        <p:spPr>
+          <a:xfrm>
+            <a:off x="4023360" y="4206240"/>
+            <a:ext cx="2743200" cy="274320"/>
+          </a:xfrm>
+          <a:prstGeom prst="rect">
+            <a:avLst/>
+          </a:prstGeom>
+          <a:noFill/>
+          <a:ln/>
+        </p:spPr>
+        <p:txBody>
+          <a:bodyPr wrap="square" lIns="0" tIns="0" rIns="0" bIns="0" rtlCol="0" anchor="t"/>
+          <a:lstStyle/>
+          <a:p>
+            <a:pPr indent="0" marL="0">
+              <a:buNone/>
+            </a:pPr>
+            <a:r>
+              <a:rPr lang="en-US" sz="1300" dirty="0">
+                <a:solidFill>
+                  <a:schemeClr val="accent5"/>
+                </a:solidFill>
+              </a:rPr>
+              <a:t>Mobile robot</a:t>
+            </a:r>
+            <a:endParaRPr lang="en-US" sz="1300" dirty="0"/>
+          </a:p>
+        </p:txBody>
+      </p:sp>
+      <p:sp>
+        <p:nvSpPr>
+          <p:cNvPr id="17" name="node-planning"/>
+          <p:cNvSpPr/>
+          <p:nvPr/>
+        </p:nvSpPr>
+        <p:spPr>
+          <a:xfrm>
+            <a:off x="4023360" y="4526280"/>
+            <a:ext cx="3108960" cy="1325880"/>
+          </a:xfrm>
+          <a:prstGeom prst="roundRect">
+            <a:avLst>
+              <a:gd name="adj" fmla="val 5517"/>
             </a:avLst>
           </a:prstGeom>
           <a:solidFill>
@@ -9886,14 +9985,14 @@
       </p:sp>
       <p:sp>
         <p:nvSpPr>
-          <p:cNvPr id="15" name="Text 13"/>
+          <p:cNvPr id="18" name="Text 16"/>
           <p:cNvSpPr txBox="1"/>
           <p:nvPr/>
         </p:nvSpPr>
         <p:spPr>
           <a:xfrm>
-            <a:off x="4206240" y="4251960"/>
-            <a:ext cx="2743200" cy="365760"/>
+            <a:off x="4206240" y="4636008"/>
+            <a:ext cx="2743200" cy="320040"/>
           </a:xfrm>
           <a:prstGeom prst="rect">
             <a:avLst/>
@@ -9922,14 +10021,14 @@
       </p:sp>
       <p:sp>
         <p:nvSpPr>
-          <p:cNvPr id="16" name="Text 14"/>
+          <p:cNvPr id="19" name="Text 17"/>
           <p:cNvSpPr txBox="1"/>
           <p:nvPr/>
         </p:nvSpPr>
         <p:spPr>
           <a:xfrm>
-            <a:off x="4206240" y="4663440"/>
-            <a:ext cx="2743200" cy="914400"/>
+            <a:off x="4206240" y="4983480"/>
+            <a:ext cx="2743200" cy="822960"/>
           </a:xfrm>
           <a:prstGeom prst="rect">
             <a:avLst/>
@@ -9945,59 +10044,59 @@
               <a:buNone/>
             </a:pPr>
             <a:r>
-              <a:rPr lang="en-US" sz="1300" dirty="0">
+              <a:rPr lang="en-US" sz="1250" dirty="0">
                 <a:solidFill>
                   <a:schemeClr val="tx2"/>
                 </a:solidFill>
               </a:rPr>
               <a:t>clearance map</a:t>
             </a:r>
-            <a:endParaRPr lang="en-US" sz="1300" dirty="0"/>
-          </a:p>
-          <a:p>
-            <a:pPr indent="0" marL="0">
-              <a:buNone/>
-            </a:pPr>
-            <a:r>
-              <a:rPr lang="en-US" sz="1300" dirty="0">
+            <a:endParaRPr lang="en-US" sz="1250" dirty="0"/>
+          </a:p>
+          <a:p>
+            <a:pPr indent="0" marL="0">
+              <a:buNone/>
+            </a:pPr>
+            <a:r>
+              <a:rPr lang="en-US" sz="1250" dirty="0">
                 <a:solidFill>
                   <a:schemeClr val="tx2"/>
                 </a:solidFill>
               </a:rPr>
               <a:t>A*, shortcut, tighten</a:t>
             </a:r>
-            <a:endParaRPr lang="en-US" sz="1300" dirty="0"/>
-          </a:p>
-          <a:p>
-            <a:pPr indent="0" marL="0">
-              <a:buNone/>
-            </a:pPr>
-            <a:r>
-              <a:rPr lang="en-US" sz="1300" dirty="0">
+            <a:endParaRPr lang="en-US" sz="1250" dirty="0"/>
+          </a:p>
+          <a:p>
+            <a:pPr indent="0" marL="0">
+              <a:buNone/>
+            </a:pPr>
+            <a:r>
+              <a:rPr lang="en-US" sz="1250" dirty="0">
                 <a:solidFill>
                   <a:schemeClr val="tx2"/>
                 </a:solidFill>
               </a:rPr>
-              <a:t>lap sequencing</a:t>
-            </a:r>
-            <a:endParaRPr lang="en-US" sz="1300" dirty="0"/>
-          </a:p>
-        </p:txBody>
-      </p:sp>
-      <p:sp>
-        <p:nvSpPr>
-          <p:cNvPr id="17" name="node-navigation"/>
+              <a:t>lap sequencing, re-planning</a:t>
+            </a:r>
+            <a:endParaRPr lang="en-US" sz="1250" dirty="0"/>
+          </a:p>
+        </p:txBody>
+      </p:sp>
+      <p:sp>
+        <p:nvSpPr>
+          <p:cNvPr id="20" name="node-navigation"/>
           <p:cNvSpPr/>
           <p:nvPr/>
         </p:nvSpPr>
         <p:spPr>
           <a:xfrm>
-            <a:off x="8321040" y="4114800"/>
-            <a:ext cx="3291840" cy="1554480"/>
+            <a:off x="8321040" y="4526280"/>
+            <a:ext cx="3291840" cy="1325880"/>
           </a:xfrm>
           <a:prstGeom prst="roundRect">
             <a:avLst>
-              <a:gd name="adj" fmla="val 4706"/>
+              <a:gd name="adj" fmla="val 5517"/>
             </a:avLst>
           </a:prstGeom>
           <a:solidFill>
@@ -10013,14 +10112,14 @@
       </p:sp>
       <p:sp>
         <p:nvSpPr>
-          <p:cNvPr id="18" name="Text 16"/>
+          <p:cNvPr id="21" name="Text 19"/>
           <p:cNvSpPr txBox="1"/>
           <p:nvPr/>
         </p:nvSpPr>
         <p:spPr>
           <a:xfrm>
-            <a:off x="8503920" y="4251960"/>
-            <a:ext cx="2926080" cy="365760"/>
+            <a:off x="8503920" y="4636008"/>
+            <a:ext cx="2926080" cy="320040"/>
           </a:xfrm>
           <a:prstGeom prst="rect">
             <a:avLst/>
@@ -10049,14 +10148,14 @@
       </p:sp>
       <p:sp>
         <p:nvSpPr>
-          <p:cNvPr id="19" name="Text 17"/>
+          <p:cNvPr id="22" name="Text 20"/>
           <p:cNvSpPr txBox="1"/>
           <p:nvPr/>
         </p:nvSpPr>
         <p:spPr>
           <a:xfrm>
-            <a:off x="8503920" y="4663440"/>
-            <a:ext cx="2926080" cy="914400"/>
+            <a:off x="8503920" y="4983480"/>
+            <a:ext cx="2926080" cy="822960"/>
           </a:xfrm>
           <a:prstGeom prst="rect">
             <a:avLst/>
@@ -10072,54 +10171,54 @@
               <a:buNone/>
             </a:pPr>
             <a:r>
-              <a:rPr lang="en-US" sz="1300" dirty="0">
+              <a:rPr lang="en-US" sz="1250" dirty="0">
                 <a:solidFill>
                   <a:schemeClr val="tx2"/>
                 </a:solidFill>
               </a:rPr>
               <a:t>pure pursuit</a:t>
             </a:r>
-            <a:endParaRPr lang="en-US" sz="1300" dirty="0"/>
-          </a:p>
-          <a:p>
-            <a:pPr indent="0" marL="0">
-              <a:buNone/>
-            </a:pPr>
-            <a:r>
-              <a:rPr lang="en-US" sz="1300" dirty="0">
+            <a:endParaRPr lang="en-US" sz="1250" dirty="0"/>
+          </a:p>
+          <a:p>
+            <a:pPr indent="0" marL="0">
+              <a:buNone/>
+            </a:pPr>
+            <a:r>
+              <a:rPr lang="en-US" sz="1250" dirty="0">
                 <a:solidFill>
                   <a:schemeClr val="tx2"/>
                 </a:solidFill>
               </a:rPr>
               <a:t>turn to final heading</a:t>
             </a:r>
-            <a:endParaRPr lang="en-US" sz="1300" dirty="0"/>
-          </a:p>
-          <a:p>
-            <a:pPr indent="0" marL="0">
-              <a:buNone/>
-            </a:pPr>
-            <a:r>
-              <a:rPr lang="en-US" sz="1300" dirty="0">
+            <a:endParaRPr lang="en-US" sz="1250" dirty="0"/>
+          </a:p>
+          <a:p>
+            <a:pPr indent="0" marL="0">
+              <a:buNone/>
+            </a:pPr>
+            <a:r>
+              <a:rPr lang="en-US" sz="1250" dirty="0">
                 <a:solidFill>
                   <a:schemeClr val="tx2"/>
                 </a:solidFill>
               </a:rPr>
-              <a:t>stop on the pose</a:t>
-            </a:r>
-            <a:endParaRPr lang="en-US" sz="1300" dirty="0"/>
-          </a:p>
-        </p:txBody>
-      </p:sp>
-      <p:sp>
-        <p:nvSpPr>
-          <p:cNvPr id="20" name="a-rgbd"/>
+              <a:t>stops on unmapped obstacles</a:t>
+            </a:r>
+            <a:endParaRPr lang="en-US" sz="1250" dirty="0"/>
+          </a:p>
+        </p:txBody>
+      </p:sp>
+      <p:sp>
+        <p:nvSpPr>
+          <p:cNvPr id="23" name="a-rgbd"/>
           <p:cNvSpPr/>
           <p:nvPr/>
         </p:nvSpPr>
         <p:spPr>
           <a:xfrm>
-            <a:off x="2926080" y="2103120"/>
+            <a:off x="2926080" y="2057400"/>
             <a:ext cx="1097280" cy="0"/>
           </a:xfrm>
           <a:prstGeom prst="line">
@@ -10137,13 +10236,13 @@
       </p:sp>
       <p:sp>
         <p:nvSpPr>
-          <p:cNvPr id="21" name="Text 19"/>
+          <p:cNvPr id="24" name="Text 22"/>
           <p:cNvSpPr txBox="1"/>
           <p:nvPr/>
         </p:nvSpPr>
         <p:spPr>
           <a:xfrm>
-            <a:off x="2971800" y="1783080"/>
+            <a:off x="2971800" y="1737360"/>
             <a:ext cx="1051560" cy="274320"/>
           </a:xfrm>
           <a:prstGeom prst="rect">
@@ -10173,13 +10272,13 @@
       </p:sp>
       <p:sp>
         <p:nvSpPr>
-          <p:cNvPr id="22" name="a-tf"/>
+          <p:cNvPr id="25" name="a-tf"/>
           <p:cNvSpPr/>
           <p:nvPr/>
         </p:nvSpPr>
         <p:spPr>
           <a:xfrm>
-            <a:off x="7132320" y="2103120"/>
+            <a:off x="7132320" y="2057400"/>
             <a:ext cx="1188720" cy="0"/>
           </a:xfrm>
           <a:prstGeom prst="line">
@@ -10197,13 +10296,13 @@
       </p:sp>
       <p:sp>
         <p:nvSpPr>
-          <p:cNvPr id="23" name="Text 21"/>
+          <p:cNvPr id="26" name="Text 24"/>
           <p:cNvSpPr txBox="1"/>
           <p:nvPr/>
         </p:nvSpPr>
         <p:spPr>
           <a:xfrm>
-            <a:off x="7132320" y="1783080"/>
+            <a:off x="7132320" y="1737360"/>
             <a:ext cx="1188720" cy="274320"/>
           </a:xfrm>
           <a:prstGeom prst="rect">
@@ -10233,13 +10332,13 @@
       </p:sp>
       <p:sp>
         <p:nvSpPr>
-          <p:cNvPr id="24" name="a-map"/>
+          <p:cNvPr id="27" name="a-map"/>
           <p:cNvSpPr/>
           <p:nvPr/>
         </p:nvSpPr>
         <p:spPr>
           <a:xfrm>
-            <a:off x="2926080" y="4572000"/>
+            <a:off x="2926080" y="4937760"/>
             <a:ext cx="1097280" cy="0"/>
           </a:xfrm>
           <a:prstGeom prst="line">
@@ -10257,13 +10356,13 @@
       </p:sp>
       <p:sp>
         <p:nvSpPr>
-          <p:cNvPr id="25" name="Text 23"/>
+          <p:cNvPr id="28" name="Text 26"/>
           <p:cNvSpPr txBox="1"/>
           <p:nvPr/>
         </p:nvSpPr>
         <p:spPr>
           <a:xfrm>
-            <a:off x="2971800" y="4251960"/>
+            <a:off x="2971800" y="4617720"/>
             <a:ext cx="1051560" cy="274320"/>
           </a:xfrm>
           <a:prstGeom prst="rect">
@@ -10293,13 +10392,13 @@
       </p:sp>
       <p:sp>
         <p:nvSpPr>
-          <p:cNvPr id="26" name="a-path"/>
+          <p:cNvPr id="29" name="a-path"/>
           <p:cNvSpPr/>
           <p:nvPr/>
         </p:nvSpPr>
         <p:spPr>
           <a:xfrm>
-            <a:off x="7132320" y="4572000"/>
+            <a:off x="7132320" y="4937760"/>
             <a:ext cx="1188720" cy="0"/>
           </a:xfrm>
           <a:prstGeom prst="line">
@@ -10317,13 +10416,13 @@
       </p:sp>
       <p:sp>
         <p:nvSpPr>
-          <p:cNvPr id="27" name="Text 25"/>
+          <p:cNvPr id="30" name="Text 28"/>
           <p:cNvSpPr txBox="1"/>
           <p:nvPr/>
         </p:nvSpPr>
         <p:spPr>
           <a:xfrm>
-            <a:off x="7132320" y="4251960"/>
+            <a:off x="7132320" y="4617720"/>
             <a:ext cx="1188720" cy="274320"/>
           </a:xfrm>
           <a:prstGeom prst="rect">
@@ -10353,14 +10452,158 @@
       </p:sp>
       <p:sp>
         <p:nvSpPr>
-          <p:cNvPr id="28" name="r-arm-1"/>
+          <p:cNvPr id="31" name="a-obstacles"/>
           <p:cNvSpPr/>
           <p:nvPr/>
         </p:nvSpPr>
         <p:spPr>
           <a:xfrm>
-            <a:off x="9966960" y="3200400"/>
-            <a:ext cx="0" cy="320040"/>
+            <a:off x="7132320" y="5440680"/>
+            <a:ext cx="1188720" cy="0"/>
+          </a:xfrm>
+          <a:prstGeom prst="line">
+            <a:avLst/>
+          </a:prstGeom>
+          <a:noFill/>
+          <a:ln w="19050">
+            <a:solidFill>
+              <a:srgbClr val="6B7280"/>
+            </a:solidFill>
+            <a:prstDash val="solid"/>
+            <a:headEnd type="triangle"/>
+          </a:ln>
+        </p:spPr>
+      </p:sp>
+      <p:sp>
+        <p:nvSpPr>
+          <p:cNvPr id="32" name="Text 30"/>
+          <p:cNvSpPr txBox="1"/>
+          <p:nvPr/>
+        </p:nvSpPr>
+        <p:spPr>
+          <a:xfrm>
+            <a:off x="7132320" y="5486400"/>
+            <a:ext cx="1188720" cy="274320"/>
+          </a:xfrm>
+          <a:prstGeom prst="rect">
+            <a:avLst/>
+          </a:prstGeom>
+          <a:noFill/>
+          <a:ln/>
+        </p:spPr>
+        <p:txBody>
+          <a:bodyPr wrap="square" lIns="0" tIns="0" rIns="0" bIns="0" rtlCol="0" anchor="t"/>
+          <a:lstStyle/>
+          <a:p>
+            <a:pPr algn="ctr" indent="0" marL="0">
+              <a:buNone/>
+            </a:pPr>
+            <a:r>
+              <a:rPr lang="en-US" sz="1100" dirty="0">
+                <a:solidFill>
+                  <a:schemeClr val="tx2"/>
+                </a:solidFill>
+              </a:rPr>
+              <a:t>/ebot_obstacles</a:t>
+            </a:r>
+            <a:endParaRPr lang="en-US" sz="1100" dirty="0"/>
+          </a:p>
+        </p:txBody>
+      </p:sp>
+      <p:sp>
+        <p:nvSpPr>
+          <p:cNvPr id="33" name="h-1"/>
+          <p:cNvSpPr/>
+          <p:nvPr/>
+        </p:nvSpPr>
+        <p:spPr>
+          <a:xfrm>
+            <a:off x="5577840" y="3886200"/>
+            <a:ext cx="0" cy="640080"/>
+          </a:xfrm>
+          <a:prstGeom prst="line">
+            <a:avLst/>
+          </a:prstGeom>
+          <a:noFill/>
+          <a:ln w="19050">
+            <a:solidFill>
+              <a:srgbClr val="C4501F"/>
+            </a:solidFill>
+            <a:prstDash val="solid"/>
+            <a:tailEnd type="triangle"/>
+          </a:ln>
+        </p:spPr>
+      </p:sp>
+      <p:sp>
+        <p:nvSpPr>
+          <p:cNvPr id="34" name="h-2"/>
+          <p:cNvSpPr/>
+          <p:nvPr/>
+        </p:nvSpPr>
+        <p:spPr>
+          <a:xfrm>
+            <a:off x="5577840" y="3886200"/>
+            <a:ext cx="2743200" cy="0"/>
+          </a:xfrm>
+          <a:prstGeom prst="line">
+            <a:avLst/>
+          </a:prstGeom>
+          <a:noFill/>
+          <a:ln w="19050">
+            <a:solidFill>
+              <a:srgbClr val="C4501F"/>
+            </a:solidFill>
+            <a:prstDash val="solid"/>
+            <a:tailEnd type="triangle"/>
+          </a:ln>
+        </p:spPr>
+      </p:sp>
+      <p:sp>
+        <p:nvSpPr>
+          <p:cNvPr id="35" name="Text 33"/>
+          <p:cNvSpPr txBox="1"/>
+          <p:nvPr/>
+        </p:nvSpPr>
+        <p:spPr>
+          <a:xfrm>
+            <a:off x="5669280" y="3584448"/>
+            <a:ext cx="2651760" cy="274320"/>
+          </a:xfrm>
+          <a:prstGeom prst="rect">
+            <a:avLst/>
+          </a:prstGeom>
+          <a:noFill/>
+          <a:ln/>
+        </p:spPr>
+        <p:txBody>
+          <a:bodyPr wrap="square" lIns="0" tIns="0" rIns="0" bIns="0" rtlCol="0" anchor="t"/>
+          <a:lstStyle/>
+          <a:p>
+            <a:pPr indent="0" marL="0">
+              <a:buNone/>
+            </a:pPr>
+            <a:r>
+              <a:rPr lang="en-US" sz="1100" dirty="0">
+                <a:solidFill>
+                  <a:schemeClr val="accent1"/>
+                </a:solidFill>
+              </a:rPr>
+              <a:t>/handoff/ready  ⇄  /handoff/done</a:t>
+            </a:r>
+            <a:endParaRPr lang="en-US" sz="1100" dirty="0"/>
+          </a:p>
+        </p:txBody>
+      </p:sp>
+      <p:sp>
+        <p:nvSpPr>
+          <p:cNvPr id="36" name="r-arm-1"/>
+          <p:cNvSpPr/>
+          <p:nvPr/>
+        </p:nvSpPr>
+        <p:spPr>
+          <a:xfrm>
+            <a:off x="9966960" y="2926080"/>
+            <a:ext cx="0" cy="274320"/>
           </a:xfrm>
           <a:prstGeom prst="line">
             <a:avLst/>
@@ -10376,13 +10619,13 @@
       </p:sp>
       <p:sp>
         <p:nvSpPr>
-          <p:cNvPr id="29" name="r-arm-2"/>
+          <p:cNvPr id="37" name="r-arm-2"/>
           <p:cNvSpPr/>
           <p:nvPr/>
         </p:nvSpPr>
         <p:spPr>
           <a:xfrm>
-            <a:off x="2926080" y="3520440"/>
+            <a:off x="2926080" y="3200400"/>
             <a:ext cx="7040880" cy="0"/>
           </a:xfrm>
           <a:prstGeom prst="line">
@@ -10394,20 +10637,20 @@
               <a:srgbClr val="6B7280"/>
             </a:solidFill>
             <a:prstDash val="solid"/>
-            <a:tailEnd type="triangle"/>
+            <a:headEnd type="triangle"/>
           </a:ln>
         </p:spPr>
       </p:sp>
       <p:sp>
         <p:nvSpPr>
-          <p:cNvPr id="30" name="Text 28"/>
+          <p:cNvPr id="38" name="Text 36"/>
           <p:cNvSpPr txBox="1"/>
           <p:nvPr/>
         </p:nvSpPr>
         <p:spPr>
           <a:xfrm>
-            <a:off x="4023360" y="3246120"/>
-            <a:ext cx="3108960" cy="274320"/>
+            <a:off x="3108960" y="3246120"/>
+            <a:ext cx="2377440" cy="274320"/>
           </a:xfrm>
           <a:prstGeom prst="rect">
             <a:avLst/>
@@ -10436,14 +10679,14 @@
       </p:sp>
       <p:sp>
         <p:nvSpPr>
-          <p:cNvPr id="31" name="r-ebot-1"/>
+          <p:cNvPr id="39" name="r-ebot-1"/>
           <p:cNvSpPr/>
           <p:nvPr/>
         </p:nvSpPr>
         <p:spPr>
           <a:xfrm>
-            <a:off x="9966960" y="5669280"/>
-            <a:ext cx="0" cy="320040"/>
+            <a:off x="9966960" y="5852160"/>
+            <a:ext cx="0" cy="274320"/>
           </a:xfrm>
           <a:prstGeom prst="line">
             <a:avLst/>
@@ -10459,13 +10702,13 @@
       </p:sp>
       <p:sp>
         <p:nvSpPr>
-          <p:cNvPr id="32" name="r-ebot-2"/>
+          <p:cNvPr id="40" name="r-ebot-2"/>
           <p:cNvSpPr/>
           <p:nvPr/>
         </p:nvSpPr>
         <p:spPr>
           <a:xfrm>
-            <a:off x="2926080" y="5989320"/>
+            <a:off x="2926080" y="6126480"/>
             <a:ext cx="7040880" cy="0"/>
           </a:xfrm>
           <a:prstGeom prst="line">
@@ -10477,19 +10720,19 @@
               <a:srgbClr val="6B7280"/>
             </a:solidFill>
             <a:prstDash val="solid"/>
-            <a:tailEnd type="triangle"/>
+            <a:headEnd type="triangle"/>
           </a:ln>
         </p:spPr>
       </p:sp>
       <p:sp>
         <p:nvSpPr>
-          <p:cNvPr id="33" name="Text 31"/>
+          <p:cNvPr id="41" name="Text 39"/>
           <p:cNvSpPr txBox="1"/>
           <p:nvPr/>
         </p:nvSpPr>
         <p:spPr>
           <a:xfrm>
-            <a:off x="4023360" y="6035040"/>
+            <a:off x="4023360" y="6144768"/>
             <a:ext cx="4114800" cy="274320"/>
           </a:xfrm>
           <a:prstGeom prst="rect">

</xml_diff>